<commit_message>
fix: update presentation with Bal Bharati Public School and resolve OpenRouter AI & CSP connect-src
</commit_message>
<xml_diff>
--- a/AgriSense_Official_12_Slides.pptx
+++ b/AgriSense_Official_12_Slides.pptx
@@ -3215,7 +3215,7 @@
               </a:defRPr>
             </a:pPr>
             <a:r>
-              <a:t>Theme / Category: Sustainable Agriculture · Precision IoT Hardware · Multilingual AI Advisory</a:t>
+              <a:t>Bal Bharati Public School  |  Theme: Sustainable Agriculture · Precision IoT · AI Advisory</a:t>
             </a:r>
           </a:p>
         </p:txBody>
@@ -3296,7 +3296,7 @@
               </a:defRPr>
             </a:pPr>
             <a:r>
-              <a:t>👥 TEAM MEMBERS</a:t>
+              <a:t>👥 TEAM MEMBERS (BAL BHARATI PUBLIC SCHOOL)</a:t>
             </a:r>
           </a:p>
         </p:txBody>
@@ -3506,6 +3506,22 @@
             <a:spAutoFit/>
           </a:bodyPr>
           <a:lstStyle/>
+          <a:p>
+            <a:pPr>
+              <a:spcBef>
+                <a:spcPts val="400"/>
+              </a:spcBef>
+              <a:defRPr sz="1050">
+                <a:solidFill>
+                  <a:srgbClr val="F1F5F9"/>
+                </a:solidFill>
+                <a:latin typeface="Arial"/>
+              </a:defRPr>
+            </a:pPr>
+            <a:r>
+              <a:t>• Institution: Bal Bharati Public School</a:t>
+            </a:r>
+          </a:p>
           <a:p>
             <a:pPr>
               <a:spcBef>
@@ -5295,7 +5311,23 @@
               </a:defRPr>
             </a:pPr>
             <a:r>
-              <a:t>• Mentor: Ms. Deepika Dutt — Continuous guidance in technical approach, research validation and problem structuring.</a:t>
+              <a:t>• Institution: Bal Bharati Public School — Fostering student innovation in sustainability &amp; AI.</a:t>
+            </a:r>
+          </a:p>
+          <a:p>
+            <a:pPr>
+              <a:spcBef>
+                <a:spcPts val="600"/>
+              </a:spcBef>
+              <a:defRPr sz="950">
+                <a:solidFill>
+                  <a:srgbClr val="F1F5F9"/>
+                </a:solidFill>
+                <a:latin typeface="Arial"/>
+              </a:defRPr>
+            </a:pPr>
+            <a:r>
+              <a:t>• Mentor: Ms. Deepika Dutt — Continuous guidance in technical approach and problem structuring.</a:t>
             </a:r>
           </a:p>
           <a:p>

</xml_diff>